<commit_message>
Rediseño de la presentacion con identidad visual sectorial
Las catorce diapositivas pasan a una paleta de azul marino y cian sobre
gris claro, con titulos en mayusculas, tarjetas blancas, tablas de
encabezado oscuro, cifras destacadas sobre banda y franjas de
conclusiones con marcas de verificacion. El contenido y las notas del
orador no cambian.

Se regeneran docs/presentacion.pdf y docs/presentacion.pptx con el nuevo
diseño.
</commit_message>
<xml_diff>
--- a/docs/presentacion.pptx
+++ b/docs/presentacion.pptx
@@ -585,7 +585,7 @@
           <a:lstStyle/>
           <a:p>
             <a:r>
-              <a:t>Ésta es la diapositiva para el público no técnico: si sólo se llevan una, que sea ésta. Las cuatro advertencias de abajo conviene decirlas nosotros, sin esperar la pregunta; queda mucho mejor que si las tiene que señalar el que escucha. El resultado negativo de la arena importada suele ser el que más engancha, porque es una decisión concreta de compra.</a:t>
+              <a:t>Ésta es la diapositiva para el público no técnico: si sólo se llevan una, que sea ésta. Las cuatro advertencias de la franja conviene decirlas nosotros, sin esperar la pregunta; queda mucho mejor que si las tiene que señalar el que escucha. El resultado negativo de la arena importada suele ser el que más engancha, porque es una decisión concreta de compra.</a:t>
             </a:r>
           </a:p>
         </p:txBody>
@@ -725,7 +725,7 @@
           <a:lstStyle/>
           <a:p>
             <a:r>
-              <a:t>La analogía para explicar no supervisado: es la diferencia entre darle a alguien mil fotos de animales ya etiquetadas y darle las mismas mil sin etiquetas, pidiéndole que arme pilas con los que se parezcan. Nadie le dice cuántas pilas ni cómo se llama cada una. El remate es el recuadro oscuro: el algoritmo no vio el año. Si preguntan por qué cuatro grupos, la respuesta corta es que los índices no coinciden —dos votan 2 y uno vota 6— y elegimos 4 por estabilidad, tamaño de grupo e interpretabilidad, argumentado en el notebook.</a:t>
+              <a:t>La analogía para explicar no supervisado: es la diferencia entre darle a alguien mil fotos de animales ya etiquetadas y darle las mismas mil sin etiquetas, pidiéndole que arme pilas con los que se parezcan. Nadie le dice cuántas pilas ni cómo se llama cada una. El remate es la franja oscura: el algoritmo no vio el año. Si preguntan por qué cuatro grupos, la respuesta corta es que los índices no coinciden —dos votan 2 y uno vota 6— y elegimos 4 por estabilidad, tamaño de grupo e interpretabilidad, argumentado en el notebook.</a:t>
             </a:r>
           </a:p>
         </p:txBody>
@@ -795,7 +795,7 @@
           <a:lstStyle/>
           <a:p>
             <a:r>
-              <a:t>Si hay una sola frase para llevarse de la cuarta entrega es la del recuadro oscuro: una variable puede ser irrelevante para predecir y central para describir. El resto de la diapositiva es la prueba de que los grupos no son un corte arbitrario del espacio: capturan una diferencia real que se manifiesta en una variable que el algoritmo nunca vio. Decir la advertencia de causalidad sin que la pregunten: entre 2015 y 2024 no cambió sólo el diseño, cambió también dónde se perfora y con qué conocimiento del reservorio.</a:t>
+              <a:t>Si hay una sola frase para llevarse de la cuarta entrega es la de la franja oscura: una variable puede ser irrelevante para predecir y central para describir. El resto de la diapositiva es la prueba de que los grupos no son un corte arbitrario del espacio: capturan una diferencia real que se manifiesta en una variable que el algoritmo nunca vio. Decir la advertencia de causalidad sin que la pregunten: entre 2015 y 2024 no cambió sólo el diseño, cambió también dónde se perfora y con qué conocimiento del reservorio.</a:t>
             </a:r>
           </a:p>
         </p:txBody>
@@ -935,7 +935,7 @@
           <a:lstStyle/>
           <a:p>
             <a:r>
-              <a:t>Treinta segundos, sin números. La esponja es la imagen que hace entender todo lo demás: el petróleo no está suelto, está adentro de la roca. Después los tres pasos: se perfora de costado, se fractura por etapas, la arena traba las grietas. Cerrar con el recuadro: estas decisiones son plata, se toman a ciegas y no se pueden deshacer. Esa es la razón por la que vale la pena estudiarlas.</a:t>
+              <a:t>Treinta segundos, sin números. La esponja es la imagen que hace entender todo lo demás: el petróleo no está suelto, está adentro de la roca. Después los tres pasos: se perfora de costado, se fractura por etapas, la arena traba las grietas. Cerrar con la franja: estas decisiones son plata, se toman a ciegas y no se pueden deshacer. Esa es la razón por la que vale la pena estudiarlas.</a:t>
             </a:r>
           </a:p>
         </p:txBody>
@@ -1005,7 +1005,7 @@
           <a:lstStyle/>
           <a:p>
             <a:r>
-              <a:t>Esta es la diapositiva donde se fija la pregunta. Leerla tal cual y hacer una pausa. Aclarar que “sabiendo sólo cómo se lo diseñó” es la restricción importante: el modelo no ve la geología ni nada que pase después de fracturar, sólo las decisiones que la operadora tomó antes. Y anticipar que la segunda pregunta —qué parte NO se explica— va a terminar siendo tan informativa como la primera.</a:t>
+              <a:t>Esta es la diapositiva donde se fija la pregunta. Leerla tal cual y hacer una pausa. Aclarar que «sabiendo sólo cómo se lo diseñó» es la restricción importante: el modelo no ve la geología ni nada que pase después de fracturar, sólo las decisiones que la operadora tomó antes. Y anticipar que la segunda pregunta —qué parte NO se explica— va a terminar siendo tan informativa como la primera.</a:t>
             </a:r>
           </a:p>
         </p:txBody>
@@ -1425,7 +1425,7 @@
           <a:lstStyle/>
           <a:p>
             <a:r>
-              <a:t>Un desvío estándar de rama son unos 900 metros, así que la primera barra se dice como “cada 900 metros más de rama, unos 7.400 m³ más de petróleo en el primer año”. El punto visual es que la primera barra es casi el triple de la segunda: la rama manda. Metros entre etapas aparece con signo negativo porque más separación es fracturar menos denso, así que apretar las etapas suma. Si preguntan por la presión máxima: la sacamos de la lista porque los dos modelos no coinciden sobre ella y es la variable con más valores imputados, así que la lectura prudente es que no aporta señal propia.</a:t>
+              <a:t>Un desvío estándar de rama son unos 900 metros, así que la primera barra se dice como «cada 900 metros más de rama, unos 7.400 m³ más de petróleo en el primer año». El punto visual es que la primera barra es casi el triple de la segunda: la rama manda. Metros entre etapas aparece con signo negativo porque más separación es fracturar menos denso, así que apretar las etapas suma. Si preguntan por la presión máxima: la sacamos de la lista porque los dos modelos no coinciden sobre ella y es la variable con más valores imputados, así que la lectura prudente es que no aporta señal propia.</a:t>
             </a:r>
           </a:p>
         </p:txBody>

</xml_diff>